<commit_message>
welcome and preparation pages
</commit_message>
<xml_diff>
--- a/images/exercises/_images_prep.pptx
+++ b/images/exercises/_images_prep.pptx
@@ -6,6 +6,7 @@
   </p:sldMasterIdLst>
   <p:sldIdLst>
     <p:sldId id="257" r:id="rId2"/>
+    <p:sldId id="258" r:id="rId3"/>
   </p:sldIdLst>
   <p:sldSz cx="12192000" cy="6858000"/>
   <p:notesSz cx="6858000" cy="9144000"/>
@@ -259,7 +260,7 @@
           <a:p>
             <a:fld id="{74771B28-E527-4BEF-A963-C3E580496725}" type="datetimeFigureOut">
               <a:rPr lang="es-ES" smtClean="0"/>
-              <a:t>19/07/2026</a:t>
+              <a:t>28/07/2026</a:t>
             </a:fld>
             <a:endParaRPr lang="es-ES"/>
           </a:p>
@@ -457,7 +458,7 @@
           <a:p>
             <a:fld id="{74771B28-E527-4BEF-A963-C3E580496725}" type="datetimeFigureOut">
               <a:rPr lang="es-ES" smtClean="0"/>
-              <a:t>19/07/2026</a:t>
+              <a:t>28/07/2026</a:t>
             </a:fld>
             <a:endParaRPr lang="es-ES"/>
           </a:p>
@@ -665,7 +666,7 @@
           <a:p>
             <a:fld id="{74771B28-E527-4BEF-A963-C3E580496725}" type="datetimeFigureOut">
               <a:rPr lang="es-ES" smtClean="0"/>
-              <a:t>19/07/2026</a:t>
+              <a:t>28/07/2026</a:t>
             </a:fld>
             <a:endParaRPr lang="es-ES"/>
           </a:p>
@@ -863,7 +864,7 @@
           <a:p>
             <a:fld id="{74771B28-E527-4BEF-A963-C3E580496725}" type="datetimeFigureOut">
               <a:rPr lang="es-ES" smtClean="0"/>
-              <a:t>19/07/2026</a:t>
+              <a:t>28/07/2026</a:t>
             </a:fld>
             <a:endParaRPr lang="es-ES"/>
           </a:p>
@@ -1138,7 +1139,7 @@
           <a:p>
             <a:fld id="{74771B28-E527-4BEF-A963-C3E580496725}" type="datetimeFigureOut">
               <a:rPr lang="es-ES" smtClean="0"/>
-              <a:t>19/07/2026</a:t>
+              <a:t>28/07/2026</a:t>
             </a:fld>
             <a:endParaRPr lang="es-ES"/>
           </a:p>
@@ -1403,7 +1404,7 @@
           <a:p>
             <a:fld id="{74771B28-E527-4BEF-A963-C3E580496725}" type="datetimeFigureOut">
               <a:rPr lang="es-ES" smtClean="0"/>
-              <a:t>19/07/2026</a:t>
+              <a:t>28/07/2026</a:t>
             </a:fld>
             <a:endParaRPr lang="es-ES"/>
           </a:p>
@@ -1815,7 +1816,7 @@
           <a:p>
             <a:fld id="{74771B28-E527-4BEF-A963-C3E580496725}" type="datetimeFigureOut">
               <a:rPr lang="es-ES" smtClean="0"/>
-              <a:t>19/07/2026</a:t>
+              <a:t>28/07/2026</a:t>
             </a:fld>
             <a:endParaRPr lang="es-ES"/>
           </a:p>
@@ -1956,7 +1957,7 @@
           <a:p>
             <a:fld id="{74771B28-E527-4BEF-A963-C3E580496725}" type="datetimeFigureOut">
               <a:rPr lang="es-ES" smtClean="0"/>
-              <a:t>19/07/2026</a:t>
+              <a:t>28/07/2026</a:t>
             </a:fld>
             <a:endParaRPr lang="es-ES"/>
           </a:p>
@@ -2069,7 +2070,7 @@
           <a:p>
             <a:fld id="{74771B28-E527-4BEF-A963-C3E580496725}" type="datetimeFigureOut">
               <a:rPr lang="es-ES" smtClean="0"/>
-              <a:t>19/07/2026</a:t>
+              <a:t>28/07/2026</a:t>
             </a:fld>
             <a:endParaRPr lang="es-ES"/>
           </a:p>
@@ -2380,7 +2381,7 @@
           <a:p>
             <a:fld id="{74771B28-E527-4BEF-A963-C3E580496725}" type="datetimeFigureOut">
               <a:rPr lang="es-ES" smtClean="0"/>
-              <a:t>19/07/2026</a:t>
+              <a:t>28/07/2026</a:t>
             </a:fld>
             <a:endParaRPr lang="es-ES"/>
           </a:p>
@@ -2668,7 +2669,7 @@
           <a:p>
             <a:fld id="{74771B28-E527-4BEF-A963-C3E580496725}" type="datetimeFigureOut">
               <a:rPr lang="es-ES" smtClean="0"/>
-              <a:t>19/07/2026</a:t>
+              <a:t>28/07/2026</a:t>
             </a:fld>
             <a:endParaRPr lang="es-ES"/>
           </a:p>
@@ -2909,7 +2910,7 @@
           <a:p>
             <a:fld id="{74771B28-E527-4BEF-A963-C3E580496725}" type="datetimeFigureOut">
               <a:rPr lang="es-ES" smtClean="0"/>
-              <a:t>19/07/2026</a:t>
+              <a:t>28/07/2026</a:t>
             </a:fld>
             <a:endParaRPr lang="es-ES"/>
           </a:p>
@@ -3482,6 +3483,301 @@
 </p:sld>
 </file>
 
+<file path=ppt/slides/slide2.xml><?xml version="1.0" encoding="utf-8"?>
+<p:sld xmlns:a="http://schemas.openxmlformats.org/drawingml/2006/main" xmlns:r="http://schemas.openxmlformats.org/officeDocument/2006/relationships" xmlns:p="http://schemas.openxmlformats.org/presentationml/2006/main">
+  <p:cSld>
+    <p:spTree>
+      <p:nvGrpSpPr>
+        <p:cNvPr id="1" name=""/>
+        <p:cNvGrpSpPr/>
+        <p:nvPr/>
+      </p:nvGrpSpPr>
+      <p:grpSpPr>
+        <a:xfrm>
+          <a:off x="0" y="0"/>
+          <a:ext cx="0" cy="0"/>
+          <a:chOff x="0" y="0"/>
+          <a:chExt cx="0" cy="0"/>
+        </a:xfrm>
+      </p:grpSpPr>
+      <p:grpSp>
+        <p:nvGrpSpPr>
+          <p:cNvPr id="14" name="Grupo 13">
+            <a:extLst>
+              <a:ext uri="{FF2B5EF4-FFF2-40B4-BE49-F238E27FC236}">
+                <a16:creationId xmlns:a16="http://schemas.microsoft.com/office/drawing/2014/main" id="{A635CDC4-9D0E-839F-56E6-0E16E6142B9F}"/>
+              </a:ext>
+            </a:extLst>
+          </p:cNvPr>
+          <p:cNvGrpSpPr/>
+          <p:nvPr/>
+        </p:nvGrpSpPr>
+        <p:grpSpPr>
+          <a:xfrm>
+            <a:off x="2718916" y="1028365"/>
+            <a:ext cx="6754168" cy="4801270"/>
+            <a:chOff x="2718916" y="1028365"/>
+            <a:chExt cx="6754168" cy="4801270"/>
+          </a:xfrm>
+        </p:grpSpPr>
+        <p:pic>
+          <p:nvPicPr>
+            <p:cNvPr id="3" name="Imagen 2">
+              <a:extLst>
+                <a:ext uri="{FF2B5EF4-FFF2-40B4-BE49-F238E27FC236}">
+                  <a16:creationId xmlns:a16="http://schemas.microsoft.com/office/drawing/2014/main" id="{F1DF64C1-8AE4-A961-BAE3-A37C9277E513}"/>
+                </a:ext>
+              </a:extLst>
+            </p:cNvPr>
+            <p:cNvPicPr>
+              <a:picLocks noChangeAspect="1"/>
+            </p:cNvPicPr>
+            <p:nvPr/>
+          </p:nvPicPr>
+          <p:blipFill>
+            <a:blip r:embed="rId2"/>
+            <a:stretch>
+              <a:fillRect/>
+            </a:stretch>
+          </p:blipFill>
+          <p:spPr>
+            <a:xfrm>
+              <a:off x="2718916" y="1028365"/>
+              <a:ext cx="6754168" cy="4801270"/>
+            </a:xfrm>
+            <a:prstGeom prst="rect">
+              <a:avLst/>
+            </a:prstGeom>
+          </p:spPr>
+        </p:pic>
+        <p:sp>
+          <p:nvSpPr>
+            <p:cNvPr id="5" name="Elipse 4">
+              <a:extLst>
+                <a:ext uri="{FF2B5EF4-FFF2-40B4-BE49-F238E27FC236}">
+                  <a16:creationId xmlns:a16="http://schemas.microsoft.com/office/drawing/2014/main" id="{681EC411-ABC8-676C-C3DB-63C787E26B24}"/>
+                </a:ext>
+              </a:extLst>
+            </p:cNvPr>
+            <p:cNvSpPr/>
+            <p:nvPr/>
+          </p:nvSpPr>
+          <p:spPr>
+            <a:xfrm>
+              <a:off x="2718916" y="2025446"/>
+              <a:ext cx="1351837" cy="481780"/>
+            </a:xfrm>
+            <a:prstGeom prst="ellipse">
+              <a:avLst/>
+            </a:prstGeom>
+            <a:noFill/>
+            <a:ln>
+              <a:solidFill>
+                <a:srgbClr val="C00000"/>
+              </a:solidFill>
+            </a:ln>
+          </p:spPr>
+          <p:style>
+            <a:lnRef idx="2">
+              <a:schemeClr val="accent1">
+                <a:shade val="15000"/>
+              </a:schemeClr>
+            </a:lnRef>
+            <a:fillRef idx="1">
+              <a:schemeClr val="accent1"/>
+            </a:fillRef>
+            <a:effectRef idx="0">
+              <a:schemeClr val="accent1"/>
+            </a:effectRef>
+            <a:fontRef idx="minor">
+              <a:schemeClr val="lt1"/>
+            </a:fontRef>
+          </p:style>
+          <p:txBody>
+            <a:bodyPr rtlCol="0" anchor="ctr"/>
+            <a:lstStyle/>
+            <a:p>
+              <a:pPr algn="ctr"/>
+              <a:endParaRPr lang="es-ES"/>
+            </a:p>
+          </p:txBody>
+        </p:sp>
+        <p:sp>
+          <p:nvSpPr>
+            <p:cNvPr id="7" name="Flecha: a la derecha 6">
+              <a:extLst>
+                <a:ext uri="{FF2B5EF4-FFF2-40B4-BE49-F238E27FC236}">
+                  <a16:creationId xmlns:a16="http://schemas.microsoft.com/office/drawing/2014/main" id="{16DDB5F2-FE87-6890-801D-A0449B5E3CF6}"/>
+                </a:ext>
+              </a:extLst>
+            </p:cNvPr>
+            <p:cNvSpPr/>
+            <p:nvPr/>
+          </p:nvSpPr>
+          <p:spPr>
+            <a:xfrm rot="12969722">
+              <a:off x="5160389" y="1381137"/>
+              <a:ext cx="651444" cy="384048"/>
+            </a:xfrm>
+            <a:prstGeom prst="rightArrow">
+              <a:avLst>
+                <a:gd name="adj1" fmla="val 50000"/>
+                <a:gd name="adj2" fmla="val 81179"/>
+              </a:avLst>
+            </a:prstGeom>
+            <a:solidFill>
+              <a:srgbClr val="C00000"/>
+            </a:solidFill>
+            <a:ln>
+              <a:noFill/>
+            </a:ln>
+          </p:spPr>
+          <p:style>
+            <a:lnRef idx="2">
+              <a:schemeClr val="accent1">
+                <a:shade val="15000"/>
+              </a:schemeClr>
+            </a:lnRef>
+            <a:fillRef idx="1">
+              <a:schemeClr val="accent1"/>
+            </a:fillRef>
+            <a:effectRef idx="0">
+              <a:schemeClr val="accent1"/>
+            </a:effectRef>
+            <a:fontRef idx="minor">
+              <a:schemeClr val="lt1"/>
+            </a:fontRef>
+          </p:style>
+          <p:txBody>
+            <a:bodyPr rtlCol="0" anchor="ctr"/>
+            <a:lstStyle/>
+            <a:p>
+              <a:pPr algn="ctr"/>
+              <a:endParaRPr lang="es-ES"/>
+            </a:p>
+          </p:txBody>
+        </p:sp>
+        <p:sp>
+          <p:nvSpPr>
+            <p:cNvPr id="11" name="Flecha: a la derecha 10">
+              <a:extLst>
+                <a:ext uri="{FF2B5EF4-FFF2-40B4-BE49-F238E27FC236}">
+                  <a16:creationId xmlns:a16="http://schemas.microsoft.com/office/drawing/2014/main" id="{4041E264-EC9E-C5F3-F5CB-C6D952BE9749}"/>
+                </a:ext>
+              </a:extLst>
+            </p:cNvPr>
+            <p:cNvSpPr/>
+            <p:nvPr/>
+          </p:nvSpPr>
+          <p:spPr>
+            <a:xfrm rot="12969722">
+              <a:off x="4160662" y="1715519"/>
+              <a:ext cx="581899" cy="304420"/>
+            </a:xfrm>
+            <a:prstGeom prst="rightArrow">
+              <a:avLst>
+                <a:gd name="adj1" fmla="val 50000"/>
+                <a:gd name="adj2" fmla="val 81179"/>
+              </a:avLst>
+            </a:prstGeom>
+            <a:solidFill>
+              <a:srgbClr val="C00000"/>
+            </a:solidFill>
+            <a:ln>
+              <a:noFill/>
+            </a:ln>
+          </p:spPr>
+          <p:style>
+            <a:lnRef idx="2">
+              <a:schemeClr val="accent1">
+                <a:shade val="15000"/>
+              </a:schemeClr>
+            </a:lnRef>
+            <a:fillRef idx="1">
+              <a:schemeClr val="accent1"/>
+            </a:fillRef>
+            <a:effectRef idx="0">
+              <a:schemeClr val="accent1"/>
+            </a:effectRef>
+            <a:fontRef idx="minor">
+              <a:schemeClr val="lt1"/>
+            </a:fontRef>
+          </p:style>
+          <p:txBody>
+            <a:bodyPr rtlCol="0" anchor="ctr"/>
+            <a:lstStyle/>
+            <a:p>
+              <a:pPr algn="ctr"/>
+              <a:endParaRPr lang="es-ES"/>
+            </a:p>
+          </p:txBody>
+        </p:sp>
+        <p:sp>
+          <p:nvSpPr>
+            <p:cNvPr id="13" name="Elipse 12">
+              <a:extLst>
+                <a:ext uri="{FF2B5EF4-FFF2-40B4-BE49-F238E27FC236}">
+                  <a16:creationId xmlns:a16="http://schemas.microsoft.com/office/drawing/2014/main" id="{F7E72EEB-FE12-6792-B901-B446EAE00734}"/>
+                </a:ext>
+              </a:extLst>
+            </p:cNvPr>
+            <p:cNvSpPr/>
+            <p:nvPr/>
+          </p:nvSpPr>
+          <p:spPr>
+            <a:xfrm>
+              <a:off x="3793392" y="1406013"/>
+              <a:ext cx="405789" cy="378636"/>
+            </a:xfrm>
+            <a:prstGeom prst="ellipse">
+              <a:avLst/>
+            </a:prstGeom>
+            <a:noFill/>
+            <a:ln>
+              <a:solidFill>
+                <a:srgbClr val="C00000"/>
+              </a:solidFill>
+            </a:ln>
+          </p:spPr>
+          <p:style>
+            <a:lnRef idx="2">
+              <a:schemeClr val="accent1">
+                <a:shade val="15000"/>
+              </a:schemeClr>
+            </a:lnRef>
+            <a:fillRef idx="1">
+              <a:schemeClr val="accent1"/>
+            </a:fillRef>
+            <a:effectRef idx="0">
+              <a:schemeClr val="accent1"/>
+            </a:effectRef>
+            <a:fontRef idx="minor">
+              <a:schemeClr val="lt1"/>
+            </a:fontRef>
+          </p:style>
+          <p:txBody>
+            <a:bodyPr rtlCol="0" anchor="ctr"/>
+            <a:lstStyle/>
+            <a:p>
+              <a:pPr algn="ctr"/>
+              <a:endParaRPr lang="es-ES"/>
+            </a:p>
+          </p:txBody>
+        </p:sp>
+      </p:grpSp>
+    </p:spTree>
+    <p:extLst>
+      <p:ext uri="{BB962C8B-B14F-4D97-AF65-F5344CB8AC3E}">
+        <p14:creationId xmlns:p14="http://schemas.microsoft.com/office/powerpoint/2010/main" val="387207284"/>
+      </p:ext>
+    </p:extLst>
+  </p:cSld>
+  <p:clrMapOvr>
+    <a:masterClrMapping/>
+  </p:clrMapOvr>
+</p:sld>
+</file>
+
 <file path=ppt/theme/theme1.xml><?xml version="1.0" encoding="utf-8"?>
 <a:theme xmlns:a="http://schemas.openxmlformats.org/drawingml/2006/main" name="Tema de Office">
   <a:themeElements>

</xml_diff>

<commit_message>
S4 complete + fixes
</commit_message>
<xml_diff>
--- a/images/exercises/_images_prep.pptx
+++ b/images/exercises/_images_prep.pptx
@@ -7,6 +7,7 @@
   <p:sldIdLst>
     <p:sldId id="257" r:id="rId2"/>
     <p:sldId id="258" r:id="rId3"/>
+    <p:sldId id="259" r:id="rId4"/>
   </p:sldIdLst>
   <p:sldSz cx="12192000" cy="6858000"/>
   <p:notesSz cx="6858000" cy="9144000"/>
@@ -260,7 +261,7 @@
           <a:p>
             <a:fld id="{74771B28-E527-4BEF-A963-C3E580496725}" type="datetimeFigureOut">
               <a:rPr lang="es-ES" smtClean="0"/>
-              <a:t>28/07/2026</a:t>
+              <a:t>03/08/2026</a:t>
             </a:fld>
             <a:endParaRPr lang="es-ES"/>
           </a:p>
@@ -458,7 +459,7 @@
           <a:p>
             <a:fld id="{74771B28-E527-4BEF-A963-C3E580496725}" type="datetimeFigureOut">
               <a:rPr lang="es-ES" smtClean="0"/>
-              <a:t>28/07/2026</a:t>
+              <a:t>03/08/2026</a:t>
             </a:fld>
             <a:endParaRPr lang="es-ES"/>
           </a:p>
@@ -666,7 +667,7 @@
           <a:p>
             <a:fld id="{74771B28-E527-4BEF-A963-C3E580496725}" type="datetimeFigureOut">
               <a:rPr lang="es-ES" smtClean="0"/>
-              <a:t>28/07/2026</a:t>
+              <a:t>03/08/2026</a:t>
             </a:fld>
             <a:endParaRPr lang="es-ES"/>
           </a:p>
@@ -864,7 +865,7 @@
           <a:p>
             <a:fld id="{74771B28-E527-4BEF-A963-C3E580496725}" type="datetimeFigureOut">
               <a:rPr lang="es-ES" smtClean="0"/>
-              <a:t>28/07/2026</a:t>
+              <a:t>03/08/2026</a:t>
             </a:fld>
             <a:endParaRPr lang="es-ES"/>
           </a:p>
@@ -1139,7 +1140,7 @@
           <a:p>
             <a:fld id="{74771B28-E527-4BEF-A963-C3E580496725}" type="datetimeFigureOut">
               <a:rPr lang="es-ES" smtClean="0"/>
-              <a:t>28/07/2026</a:t>
+              <a:t>03/08/2026</a:t>
             </a:fld>
             <a:endParaRPr lang="es-ES"/>
           </a:p>
@@ -1404,7 +1405,7 @@
           <a:p>
             <a:fld id="{74771B28-E527-4BEF-A963-C3E580496725}" type="datetimeFigureOut">
               <a:rPr lang="es-ES" smtClean="0"/>
-              <a:t>28/07/2026</a:t>
+              <a:t>03/08/2026</a:t>
             </a:fld>
             <a:endParaRPr lang="es-ES"/>
           </a:p>
@@ -1816,7 +1817,7 @@
           <a:p>
             <a:fld id="{74771B28-E527-4BEF-A963-C3E580496725}" type="datetimeFigureOut">
               <a:rPr lang="es-ES" smtClean="0"/>
-              <a:t>28/07/2026</a:t>
+              <a:t>03/08/2026</a:t>
             </a:fld>
             <a:endParaRPr lang="es-ES"/>
           </a:p>
@@ -1957,7 +1958,7 @@
           <a:p>
             <a:fld id="{74771B28-E527-4BEF-A963-C3E580496725}" type="datetimeFigureOut">
               <a:rPr lang="es-ES" smtClean="0"/>
-              <a:t>28/07/2026</a:t>
+              <a:t>03/08/2026</a:t>
             </a:fld>
             <a:endParaRPr lang="es-ES"/>
           </a:p>
@@ -2070,7 +2071,7 @@
           <a:p>
             <a:fld id="{74771B28-E527-4BEF-A963-C3E580496725}" type="datetimeFigureOut">
               <a:rPr lang="es-ES" smtClean="0"/>
-              <a:t>28/07/2026</a:t>
+              <a:t>03/08/2026</a:t>
             </a:fld>
             <a:endParaRPr lang="es-ES"/>
           </a:p>
@@ -2381,7 +2382,7 @@
           <a:p>
             <a:fld id="{74771B28-E527-4BEF-A963-C3E580496725}" type="datetimeFigureOut">
               <a:rPr lang="es-ES" smtClean="0"/>
-              <a:t>28/07/2026</a:t>
+              <a:t>03/08/2026</a:t>
             </a:fld>
             <a:endParaRPr lang="es-ES"/>
           </a:p>
@@ -2669,7 +2670,7 @@
           <a:p>
             <a:fld id="{74771B28-E527-4BEF-A963-C3E580496725}" type="datetimeFigureOut">
               <a:rPr lang="es-ES" smtClean="0"/>
-              <a:t>28/07/2026</a:t>
+              <a:t>03/08/2026</a:t>
             </a:fld>
             <a:endParaRPr lang="es-ES"/>
           </a:p>
@@ -2910,7 +2911,7 @@
           <a:p>
             <a:fld id="{74771B28-E527-4BEF-A963-C3E580496725}" type="datetimeFigureOut">
               <a:rPr lang="es-ES" smtClean="0"/>
-              <a:t>28/07/2026</a:t>
+              <a:t>03/08/2026</a:t>
             </a:fld>
             <a:endParaRPr lang="es-ES"/>
           </a:p>
@@ -3778,6 +3779,179 @@
 </p:sld>
 </file>
 
+<file path=ppt/slides/slide3.xml><?xml version="1.0" encoding="utf-8"?>
+<p:sld xmlns:a="http://schemas.openxmlformats.org/drawingml/2006/main" xmlns:r="http://schemas.openxmlformats.org/officeDocument/2006/relationships" xmlns:p="http://schemas.openxmlformats.org/presentationml/2006/main">
+  <p:cSld>
+    <p:spTree>
+      <p:nvGrpSpPr>
+        <p:cNvPr id="1" name=""/>
+        <p:cNvGrpSpPr/>
+        <p:nvPr/>
+      </p:nvGrpSpPr>
+      <p:grpSpPr>
+        <a:xfrm>
+          <a:off x="0" y="0"/>
+          <a:ext cx="0" cy="0"/>
+          <a:chOff x="0" y="0"/>
+          <a:chExt cx="0" cy="0"/>
+        </a:xfrm>
+      </p:grpSpPr>
+      <p:pic>
+        <p:nvPicPr>
+          <p:cNvPr id="3" name="Imagen 2">
+            <a:extLst>
+              <a:ext uri="{FF2B5EF4-FFF2-40B4-BE49-F238E27FC236}">
+                <a16:creationId xmlns:a16="http://schemas.microsoft.com/office/drawing/2014/main" id="{29497665-8D08-C72A-F417-B97018959F06}"/>
+              </a:ext>
+            </a:extLst>
+          </p:cNvPr>
+          <p:cNvPicPr>
+            <a:picLocks noChangeAspect="1"/>
+          </p:cNvPicPr>
+          <p:nvPr/>
+        </p:nvPicPr>
+        <p:blipFill>
+          <a:blip r:embed="rId2">
+            <a:extLst>
+              <a:ext uri="{28A0092B-C50C-407E-A947-70E740481C1C}">
+                <a14:useLocalDpi xmlns:a14="http://schemas.microsoft.com/office/drawing/2010/main" val="0"/>
+              </a:ext>
+            </a:extLst>
+          </a:blip>
+          <a:stretch>
+            <a:fillRect/>
+          </a:stretch>
+        </p:blipFill>
+        <p:spPr>
+          <a:xfrm>
+            <a:off x="3611664" y="1523835"/>
+            <a:ext cx="4968671" cy="3810330"/>
+          </a:xfrm>
+          <a:prstGeom prst="rect">
+            <a:avLst/>
+          </a:prstGeom>
+        </p:spPr>
+      </p:pic>
+      <p:sp>
+        <p:nvSpPr>
+          <p:cNvPr id="5" name="Elipse 4">
+            <a:extLst>
+              <a:ext uri="{FF2B5EF4-FFF2-40B4-BE49-F238E27FC236}">
+                <a16:creationId xmlns:a16="http://schemas.microsoft.com/office/drawing/2014/main" id="{E636D89C-E781-D7BF-0517-7007AE21E45E}"/>
+              </a:ext>
+            </a:extLst>
+          </p:cNvPr>
+          <p:cNvSpPr/>
+          <p:nvPr/>
+        </p:nvSpPr>
+        <p:spPr>
+          <a:xfrm>
+            <a:off x="6349780" y="1809136"/>
+            <a:ext cx="365653" cy="324464"/>
+          </a:xfrm>
+          <a:prstGeom prst="ellipse">
+            <a:avLst/>
+          </a:prstGeom>
+          <a:noFill/>
+          <a:ln>
+            <a:solidFill>
+              <a:srgbClr val="C00000"/>
+            </a:solidFill>
+          </a:ln>
+        </p:spPr>
+        <p:style>
+          <a:lnRef idx="2">
+            <a:schemeClr val="accent1">
+              <a:shade val="15000"/>
+            </a:schemeClr>
+          </a:lnRef>
+          <a:fillRef idx="1">
+            <a:schemeClr val="accent1"/>
+          </a:fillRef>
+          <a:effectRef idx="0">
+            <a:schemeClr val="accent1"/>
+          </a:effectRef>
+          <a:fontRef idx="minor">
+            <a:schemeClr val="lt1"/>
+          </a:fontRef>
+        </p:style>
+        <p:txBody>
+          <a:bodyPr rtlCol="0" anchor="ctr"/>
+          <a:lstStyle/>
+          <a:p>
+            <a:pPr algn="ctr"/>
+            <a:endParaRPr lang="es-ES"/>
+          </a:p>
+        </p:txBody>
+      </p:sp>
+      <p:sp>
+        <p:nvSpPr>
+          <p:cNvPr id="7" name="Flecha: a la derecha 6">
+            <a:extLst>
+              <a:ext uri="{FF2B5EF4-FFF2-40B4-BE49-F238E27FC236}">
+                <a16:creationId xmlns:a16="http://schemas.microsoft.com/office/drawing/2014/main" id="{E9AF3027-0A88-497B-A713-6BD28AF36436}"/>
+              </a:ext>
+            </a:extLst>
+          </p:cNvPr>
+          <p:cNvSpPr/>
+          <p:nvPr/>
+        </p:nvSpPr>
+        <p:spPr>
+          <a:xfrm rot="12969722">
+            <a:off x="6635196" y="1981389"/>
+            <a:ext cx="581899" cy="304420"/>
+          </a:xfrm>
+          <a:prstGeom prst="rightArrow">
+            <a:avLst>
+              <a:gd name="adj1" fmla="val 50000"/>
+              <a:gd name="adj2" fmla="val 81179"/>
+            </a:avLst>
+          </a:prstGeom>
+          <a:solidFill>
+            <a:srgbClr val="C00000"/>
+          </a:solidFill>
+          <a:ln>
+            <a:noFill/>
+          </a:ln>
+        </p:spPr>
+        <p:style>
+          <a:lnRef idx="2">
+            <a:schemeClr val="accent1">
+              <a:shade val="15000"/>
+            </a:schemeClr>
+          </a:lnRef>
+          <a:fillRef idx="1">
+            <a:schemeClr val="accent1"/>
+          </a:fillRef>
+          <a:effectRef idx="0">
+            <a:schemeClr val="accent1"/>
+          </a:effectRef>
+          <a:fontRef idx="minor">
+            <a:schemeClr val="lt1"/>
+          </a:fontRef>
+        </p:style>
+        <p:txBody>
+          <a:bodyPr rtlCol="0" anchor="ctr"/>
+          <a:lstStyle/>
+          <a:p>
+            <a:pPr algn="ctr"/>
+            <a:endParaRPr lang="es-ES"/>
+          </a:p>
+        </p:txBody>
+      </p:sp>
+    </p:spTree>
+    <p:extLst>
+      <p:ext uri="{BB962C8B-B14F-4D97-AF65-F5344CB8AC3E}">
+        <p14:creationId xmlns:p14="http://schemas.microsoft.com/office/powerpoint/2010/main" val="3046995511"/>
+      </p:ext>
+    </p:extLst>
+  </p:cSld>
+  <p:clrMapOvr>
+    <a:masterClrMapping/>
+  </p:clrMapOvr>
+</p:sld>
+</file>
+
 <file path=ppt/theme/theme1.xml><?xml version="1.0" encoding="utf-8"?>
 <a:theme xmlns:a="http://schemas.openxmlformats.org/drawingml/2006/main" name="Tema de Office">
   <a:themeElements>

</xml_diff>

<commit_message>
S5 exercises + fix S4E4 size
</commit_message>
<xml_diff>
--- a/images/exercises/_images_prep.pptx
+++ b/images/exercises/_images_prep.pptx
@@ -8,6 +8,7 @@
     <p:sldId id="257" r:id="rId2"/>
     <p:sldId id="258" r:id="rId3"/>
     <p:sldId id="259" r:id="rId4"/>
+    <p:sldId id="260" r:id="rId5"/>
   </p:sldIdLst>
   <p:sldSz cx="12192000" cy="6858000"/>
   <p:notesSz cx="6858000" cy="9144000"/>
@@ -261,7 +262,7 @@
           <a:p>
             <a:fld id="{74771B28-E527-4BEF-A963-C3E580496725}" type="datetimeFigureOut">
               <a:rPr lang="es-ES" smtClean="0"/>
-              <a:t>03/08/2026</a:t>
+              <a:t>09/08/2026</a:t>
             </a:fld>
             <a:endParaRPr lang="es-ES"/>
           </a:p>
@@ -459,7 +460,7 @@
           <a:p>
             <a:fld id="{74771B28-E527-4BEF-A963-C3E580496725}" type="datetimeFigureOut">
               <a:rPr lang="es-ES" smtClean="0"/>
-              <a:t>03/08/2026</a:t>
+              <a:t>09/08/2026</a:t>
             </a:fld>
             <a:endParaRPr lang="es-ES"/>
           </a:p>
@@ -667,7 +668,7 @@
           <a:p>
             <a:fld id="{74771B28-E527-4BEF-A963-C3E580496725}" type="datetimeFigureOut">
               <a:rPr lang="es-ES" smtClean="0"/>
-              <a:t>03/08/2026</a:t>
+              <a:t>09/08/2026</a:t>
             </a:fld>
             <a:endParaRPr lang="es-ES"/>
           </a:p>
@@ -865,7 +866,7 @@
           <a:p>
             <a:fld id="{74771B28-E527-4BEF-A963-C3E580496725}" type="datetimeFigureOut">
               <a:rPr lang="es-ES" smtClean="0"/>
-              <a:t>03/08/2026</a:t>
+              <a:t>09/08/2026</a:t>
             </a:fld>
             <a:endParaRPr lang="es-ES"/>
           </a:p>
@@ -1140,7 +1141,7 @@
           <a:p>
             <a:fld id="{74771B28-E527-4BEF-A963-C3E580496725}" type="datetimeFigureOut">
               <a:rPr lang="es-ES" smtClean="0"/>
-              <a:t>03/08/2026</a:t>
+              <a:t>09/08/2026</a:t>
             </a:fld>
             <a:endParaRPr lang="es-ES"/>
           </a:p>
@@ -1405,7 +1406,7 @@
           <a:p>
             <a:fld id="{74771B28-E527-4BEF-A963-C3E580496725}" type="datetimeFigureOut">
               <a:rPr lang="es-ES" smtClean="0"/>
-              <a:t>03/08/2026</a:t>
+              <a:t>09/08/2026</a:t>
             </a:fld>
             <a:endParaRPr lang="es-ES"/>
           </a:p>
@@ -1817,7 +1818,7 @@
           <a:p>
             <a:fld id="{74771B28-E527-4BEF-A963-C3E580496725}" type="datetimeFigureOut">
               <a:rPr lang="es-ES" smtClean="0"/>
-              <a:t>03/08/2026</a:t>
+              <a:t>09/08/2026</a:t>
             </a:fld>
             <a:endParaRPr lang="es-ES"/>
           </a:p>
@@ -1958,7 +1959,7 @@
           <a:p>
             <a:fld id="{74771B28-E527-4BEF-A963-C3E580496725}" type="datetimeFigureOut">
               <a:rPr lang="es-ES" smtClean="0"/>
-              <a:t>03/08/2026</a:t>
+              <a:t>09/08/2026</a:t>
             </a:fld>
             <a:endParaRPr lang="es-ES"/>
           </a:p>
@@ -2071,7 +2072,7 @@
           <a:p>
             <a:fld id="{74771B28-E527-4BEF-A963-C3E580496725}" type="datetimeFigureOut">
               <a:rPr lang="es-ES" smtClean="0"/>
-              <a:t>03/08/2026</a:t>
+              <a:t>09/08/2026</a:t>
             </a:fld>
             <a:endParaRPr lang="es-ES"/>
           </a:p>
@@ -2382,7 +2383,7 @@
           <a:p>
             <a:fld id="{74771B28-E527-4BEF-A963-C3E580496725}" type="datetimeFigureOut">
               <a:rPr lang="es-ES" smtClean="0"/>
-              <a:t>03/08/2026</a:t>
+              <a:t>09/08/2026</a:t>
             </a:fld>
             <a:endParaRPr lang="es-ES"/>
           </a:p>
@@ -2670,7 +2671,7 @@
           <a:p>
             <a:fld id="{74771B28-E527-4BEF-A963-C3E580496725}" type="datetimeFigureOut">
               <a:rPr lang="es-ES" smtClean="0"/>
-              <a:t>03/08/2026</a:t>
+              <a:t>09/08/2026</a:t>
             </a:fld>
             <a:endParaRPr lang="es-ES"/>
           </a:p>
@@ -2911,7 +2912,7 @@
           <a:p>
             <a:fld id="{74771B28-E527-4BEF-A963-C3E580496725}" type="datetimeFigureOut">
               <a:rPr lang="es-ES" smtClean="0"/>
-              <a:t>03/08/2026</a:t>
+              <a:t>09/08/2026</a:t>
             </a:fld>
             <a:endParaRPr lang="es-ES"/>
           </a:p>
@@ -3952,6 +3953,288 @@
 </p:sld>
 </file>
 
+<file path=ppt/slides/slide4.xml><?xml version="1.0" encoding="utf-8"?>
+<p:sld xmlns:a="http://schemas.openxmlformats.org/drawingml/2006/main" xmlns:r="http://schemas.openxmlformats.org/officeDocument/2006/relationships" xmlns:p="http://schemas.openxmlformats.org/presentationml/2006/main">
+  <p:cSld>
+    <p:spTree>
+      <p:nvGrpSpPr>
+        <p:cNvPr id="1" name=""/>
+        <p:cNvGrpSpPr/>
+        <p:nvPr/>
+      </p:nvGrpSpPr>
+      <p:grpSpPr>
+        <a:xfrm>
+          <a:off x="0" y="0"/>
+          <a:ext cx="0" cy="0"/>
+          <a:chOff x="0" y="0"/>
+          <a:chExt cx="0" cy="0"/>
+        </a:xfrm>
+      </p:grpSpPr>
+      <p:grpSp>
+        <p:nvGrpSpPr>
+          <p:cNvPr id="2" name="Grupo 1">
+            <a:extLst>
+              <a:ext uri="{FF2B5EF4-FFF2-40B4-BE49-F238E27FC236}">
+                <a16:creationId xmlns:a16="http://schemas.microsoft.com/office/drawing/2014/main" id="{F07A1EB5-81DA-8057-A080-F6C187411537}"/>
+              </a:ext>
+            </a:extLst>
+          </p:cNvPr>
+          <p:cNvGrpSpPr/>
+          <p:nvPr/>
+        </p:nvGrpSpPr>
+        <p:grpSpPr>
+          <a:xfrm>
+            <a:off x="903515" y="732973"/>
+            <a:ext cx="10537372" cy="1574798"/>
+            <a:chOff x="624101" y="768151"/>
+            <a:chExt cx="9531171" cy="1451155"/>
+          </a:xfrm>
+        </p:grpSpPr>
+        <p:pic>
+          <p:nvPicPr>
+            <p:cNvPr id="3" name="Imagen 2">
+              <a:extLst>
+                <a:ext uri="{FF2B5EF4-FFF2-40B4-BE49-F238E27FC236}">
+                  <a16:creationId xmlns:a16="http://schemas.microsoft.com/office/drawing/2014/main" id="{B8C56762-C29C-E91E-3E04-0817DE899915}"/>
+                </a:ext>
+              </a:extLst>
+            </p:cNvPr>
+            <p:cNvPicPr>
+              <a:picLocks noChangeAspect="1"/>
+            </p:cNvPicPr>
+            <p:nvPr/>
+          </p:nvPicPr>
+          <p:blipFill>
+            <a:blip r:embed="rId2"/>
+            <a:stretch>
+              <a:fillRect/>
+            </a:stretch>
+          </p:blipFill>
+          <p:spPr>
+            <a:xfrm>
+              <a:off x="624101" y="832578"/>
+              <a:ext cx="1333436" cy="1333436"/>
+            </a:xfrm>
+            <a:prstGeom prst="rect">
+              <a:avLst/>
+            </a:prstGeom>
+          </p:spPr>
+        </p:pic>
+        <p:pic>
+          <p:nvPicPr>
+            <p:cNvPr id="4" name="Imagen 3">
+              <a:extLst>
+                <a:ext uri="{FF2B5EF4-FFF2-40B4-BE49-F238E27FC236}">
+                  <a16:creationId xmlns:a16="http://schemas.microsoft.com/office/drawing/2014/main" id="{C33F59EB-2085-2675-9D61-77D2BAC6297A}"/>
+                </a:ext>
+              </a:extLst>
+            </p:cNvPr>
+            <p:cNvPicPr>
+              <a:picLocks noChangeAspect="1"/>
+            </p:cNvPicPr>
+            <p:nvPr/>
+          </p:nvPicPr>
+          <p:blipFill>
+            <a:blip r:embed="rId3"/>
+            <a:stretch>
+              <a:fillRect/>
+            </a:stretch>
+          </p:blipFill>
+          <p:spPr>
+            <a:xfrm>
+              <a:off x="3915003" y="885870"/>
+              <a:ext cx="1244890" cy="1244890"/>
+            </a:xfrm>
+            <a:prstGeom prst="rect">
+              <a:avLst/>
+            </a:prstGeom>
+          </p:spPr>
+        </p:pic>
+        <p:grpSp>
+          <p:nvGrpSpPr>
+            <p:cNvPr id="5" name="Grupo 4">
+              <a:extLst>
+                <a:ext uri="{FF2B5EF4-FFF2-40B4-BE49-F238E27FC236}">
+                  <a16:creationId xmlns:a16="http://schemas.microsoft.com/office/drawing/2014/main" id="{917E04DD-9EA1-A611-39E3-6B38238A6433}"/>
+                </a:ext>
+              </a:extLst>
+            </p:cNvPr>
+            <p:cNvGrpSpPr/>
+            <p:nvPr/>
+          </p:nvGrpSpPr>
+          <p:grpSpPr>
+            <a:xfrm>
+              <a:off x="2112310" y="801179"/>
+              <a:ext cx="1375574" cy="1414271"/>
+              <a:chOff x="4242956" y="464531"/>
+              <a:chExt cx="2489525" cy="2441229"/>
+            </a:xfrm>
+          </p:grpSpPr>
+          <p:pic>
+            <p:nvPicPr>
+              <p:cNvPr id="9" name="Imagen 8">
+                <a:extLst>
+                  <a:ext uri="{FF2B5EF4-FFF2-40B4-BE49-F238E27FC236}">
+                    <a16:creationId xmlns:a16="http://schemas.microsoft.com/office/drawing/2014/main" id="{A8104C49-0875-0D45-FE7F-16FFA8E5362A}"/>
+                  </a:ext>
+                </a:extLst>
+              </p:cNvPr>
+              <p:cNvPicPr>
+                <a:picLocks noChangeAspect="1"/>
+              </p:cNvPicPr>
+              <p:nvPr/>
+            </p:nvPicPr>
+            <p:blipFill>
+              <a:blip r:embed="rId4"/>
+              <a:stretch>
+                <a:fillRect/>
+              </a:stretch>
+            </p:blipFill>
+            <p:spPr>
+              <a:xfrm>
+                <a:off x="4242956" y="464531"/>
+                <a:ext cx="2441229" cy="2441229"/>
+              </a:xfrm>
+              <a:prstGeom prst="rect">
+                <a:avLst/>
+              </a:prstGeom>
+            </p:spPr>
+          </p:pic>
+          <p:pic>
+            <p:nvPicPr>
+              <p:cNvPr id="10" name="Imagen 9">
+                <a:extLst>
+                  <a:ext uri="{FF2B5EF4-FFF2-40B4-BE49-F238E27FC236}">
+                    <a16:creationId xmlns:a16="http://schemas.microsoft.com/office/drawing/2014/main" id="{DEF98165-AF6D-8578-A9D3-0B502B9CB520}"/>
+                  </a:ext>
+                </a:extLst>
+              </p:cNvPr>
+              <p:cNvPicPr>
+                <a:picLocks noChangeAspect="1"/>
+              </p:cNvPicPr>
+              <p:nvPr/>
+            </p:nvPicPr>
+            <p:blipFill>
+              <a:blip r:embed="rId5"/>
+              <a:stretch>
+                <a:fillRect/>
+              </a:stretch>
+            </p:blipFill>
+            <p:spPr>
+              <a:xfrm>
+                <a:off x="6096000" y="2116436"/>
+                <a:ext cx="636481" cy="636481"/>
+              </a:xfrm>
+              <a:prstGeom prst="rect">
+                <a:avLst/>
+              </a:prstGeom>
+            </p:spPr>
+          </p:pic>
+        </p:grpSp>
+        <p:pic>
+          <p:nvPicPr>
+            <p:cNvPr id="6" name="Imagen 5">
+              <a:extLst>
+                <a:ext uri="{FF2B5EF4-FFF2-40B4-BE49-F238E27FC236}">
+                  <a16:creationId xmlns:a16="http://schemas.microsoft.com/office/drawing/2014/main" id="{DCC24B53-E6B1-7464-8423-C47852D2CF3A}"/>
+                </a:ext>
+              </a:extLst>
+            </p:cNvPr>
+            <p:cNvPicPr>
+              <a:picLocks noChangeAspect="1"/>
+            </p:cNvPicPr>
+            <p:nvPr/>
+          </p:nvPicPr>
+          <p:blipFill>
+            <a:blip r:embed="rId6"/>
+            <a:stretch>
+              <a:fillRect/>
+            </a:stretch>
+          </p:blipFill>
+          <p:spPr>
+            <a:xfrm>
+              <a:off x="5403907" y="805035"/>
+              <a:ext cx="1288186" cy="1288186"/>
+            </a:xfrm>
+            <a:prstGeom prst="rect">
+              <a:avLst/>
+            </a:prstGeom>
+          </p:spPr>
+        </p:pic>
+        <p:pic>
+          <p:nvPicPr>
+            <p:cNvPr id="7" name="Imagen 6">
+              <a:extLst>
+                <a:ext uri="{FF2B5EF4-FFF2-40B4-BE49-F238E27FC236}">
+                  <a16:creationId xmlns:a16="http://schemas.microsoft.com/office/drawing/2014/main" id="{0B3DDF67-8874-28CA-FD6B-816D0085BFFD}"/>
+                </a:ext>
+              </a:extLst>
+            </p:cNvPr>
+            <p:cNvPicPr>
+              <a:picLocks noChangeAspect="1"/>
+            </p:cNvPicPr>
+            <p:nvPr/>
+          </p:nvPicPr>
+          <p:blipFill>
+            <a:blip r:embed="rId7"/>
+            <a:stretch>
+              <a:fillRect/>
+            </a:stretch>
+          </p:blipFill>
+          <p:spPr>
+            <a:xfrm>
+              <a:off x="7102013" y="845453"/>
+              <a:ext cx="1288186" cy="1288186"/>
+            </a:xfrm>
+            <a:prstGeom prst="rect">
+              <a:avLst/>
+            </a:prstGeom>
+          </p:spPr>
+        </p:pic>
+        <p:pic>
+          <p:nvPicPr>
+            <p:cNvPr id="8" name="Imagen 7">
+              <a:extLst>
+                <a:ext uri="{FF2B5EF4-FFF2-40B4-BE49-F238E27FC236}">
+                  <a16:creationId xmlns:a16="http://schemas.microsoft.com/office/drawing/2014/main" id="{BD04D958-A329-9473-E1DC-0DC832B7DABC}"/>
+                </a:ext>
+              </a:extLst>
+            </p:cNvPr>
+            <p:cNvPicPr>
+              <a:picLocks noChangeAspect="1"/>
+            </p:cNvPicPr>
+            <p:nvPr/>
+          </p:nvPicPr>
+          <p:blipFill>
+            <a:blip r:embed="rId8"/>
+            <a:stretch>
+              <a:fillRect/>
+            </a:stretch>
+          </p:blipFill>
+          <p:spPr>
+            <a:xfrm>
+              <a:off x="8704117" y="768151"/>
+              <a:ext cx="1451155" cy="1451155"/>
+            </a:xfrm>
+            <a:prstGeom prst="rect">
+              <a:avLst/>
+            </a:prstGeom>
+          </p:spPr>
+        </p:pic>
+      </p:grpSp>
+    </p:spTree>
+    <p:extLst>
+      <p:ext uri="{BB962C8B-B14F-4D97-AF65-F5344CB8AC3E}">
+        <p14:creationId xmlns:p14="http://schemas.microsoft.com/office/powerpoint/2010/main" val="3782064987"/>
+      </p:ext>
+    </p:extLst>
+  </p:cSld>
+  <p:clrMapOvr>
+    <a:masterClrMapping/>
+  </p:clrMapOvr>
+</p:sld>
+</file>
+
 <file path=ppt/theme/theme1.xml><?xml version="1.0" encoding="utf-8"?>
 <a:theme xmlns:a="http://schemas.openxmlformats.org/drawingml/2006/main" name="Tema de Office">
   <a:themeElements>

</xml_diff>